<commit_message>
docs: substantiate scoped contribution after baseline import
</commit_message>
<xml_diff>
--- a/deliverables/demo/figures/论文图源.pptx
+++ b/deliverables/demo/figures/论文图源.pptx
@@ -2,15 +2,15 @@
 <file path=ppt/presentation.xml><?xml version="1.0" encoding="utf-8"?>
 <p:presentation xmlns:p="http://schemas.openxmlformats.org/presentationml/2006/main">
   <p:sldMasterIdLst>
-    <p:sldMasterId xmlns:r="http://schemas.openxmlformats.org/officeDocument/2006/relationships" id="2147483648" r:id="Rd4856098d13044f8"/>
+    <p:sldMasterId xmlns:r="http://schemas.openxmlformats.org/officeDocument/2006/relationships" id="2147483648" r:id="R675537070ed04bb5"/>
   </p:sldMasterIdLst>
   <p:notesMasterIdLst>
-    <p:notesMasterId xmlns:r="http://schemas.openxmlformats.org/officeDocument/2006/relationships" r:id="Rdae70a5935ae4cc5"/>
+    <p:notesMasterId xmlns:r="http://schemas.openxmlformats.org/officeDocument/2006/relationships" r:id="Rdf02a3d0d615495e"/>
   </p:notesMasterIdLst>
   <p:sldIdLst>
-    <p:sldId xmlns:r="http://schemas.openxmlformats.org/officeDocument/2006/relationships" id="256" r:id="R99867c1af43f415c"/>
-    <p:sldId xmlns:r="http://schemas.openxmlformats.org/officeDocument/2006/relationships" id="257" r:id="R8fb9607166fd4b26"/>
-    <p:sldId xmlns:r="http://schemas.openxmlformats.org/officeDocument/2006/relationships" id="258" r:id="R2249203090664c36"/>
+    <p:sldId xmlns:r="http://schemas.openxmlformats.org/officeDocument/2006/relationships" id="256" r:id="Ref71d49ceddc4414"/>
+    <p:sldId xmlns:r="http://schemas.openxmlformats.org/officeDocument/2006/relationships" id="257" r:id="R108efa37d9604502"/>
+    <p:sldId xmlns:r="http://schemas.openxmlformats.org/officeDocument/2006/relationships" id="258" r:id="R8a9a5c3aafa14e7f"/>
   </p:sldIdLst>
   <p:sldSz cx="5486400" cy="3086100"/>
   <p:notesSz cx="6858000" cy="9144000"/>
@@ -584,7 +584,7 @@
           <a:lstStyle xmlns:a="http://schemas.openxmlformats.org/drawingml/2006/main"/>
           <a:p xmlns:a="http://schemas.openxmlformats.org/drawingml/2006/main">
             <a:r>
-              <a:t>来源：docs/evidence/controlled-comparison-20261007/confirmation-results/comparison.report。C=0.080189s，SciPy=56.401718s，均为24进程合计。数据/全部2^20交换/判定一致。图用对数刻度展示差异，不是密码解封装加速、纯内核速度或检出能力提升。</a:t>
+              <a:t>来源：docs/evidence/controlled-comparison-20261007/confirmation-results/comparison.report及docs/evidence/warm-replay-20261007/formal/comparison.report。完整进程C=0.080189s、SciPy=56.401718s；预导入C=0.079016s、SciPy就绪后=49.704188s，准备6.559904s单独保留。全部8份既有任务、48次各次精确尾计数一致。两条件分别测量，不能相减估计启动成本。后者是成本边界敏感性补充而非新独立确认。图为对数刻度，不是密码解封装或纯内核加速、不是统计灵敏度增益。</a:t>
             </a:r>
           </a:p>
         </p:txBody>
@@ -652,7 +652,7 @@
   </p:cSld>
   <p:clrMap bg1="lt1" tx1="dk1" bg2="lt2" tx2="dk2" accent1="accent1" accent2="accent2" accent3="accent3" accent4="accent4" accent5="accent5" accent6="accent6" hlink="hlink" folHlink="folHlink"/>
   <p:sldLayoutIdLst>
-    <p:sldLayoutId xmlns:r="http://schemas.openxmlformats.org/officeDocument/2006/relationships" id="2147483649" r:id="Rac6c2a1e14d5428a"/>
+    <p:sldLayoutId xmlns:r="http://schemas.openxmlformats.org/officeDocument/2006/relationships" id="2147483649" r:id="Rffa0453ff5ee4e8c"/>
   </p:sldLayoutIdLst>
   <p:txStyles>
     <p:titleStyle>
@@ -1629,7 +1629,48 @@
           <c:idx val="0"/>
           <c:order val="0"/>
           <c:tx>
-            <c:v>完整进程成本合计 / s</c:v>
+            <c:v>C11</c:v>
+          </c:tx>
+          <c:spPr>
+            <a:solidFill xmlns:a="http://schemas.openxmlformats.org/drawingml/2006/main">
+              <a:srgbClr val="444444"/>
+            </a:solidFill>
+          </c:spPr>
+          <c:cat>
+            <c:strRef>
+              <c:f>'Chart Data'!$A$2:$A$3</c:f>
+              <c:strCache>
+                <c:ptCount val="2"/>
+                <c:pt idx="0">
+                  <c:v>完整进程</c:v>
+                </c:pt>
+                <c:pt idx="1">
+                  <c:v>SciPy预导入</c:v>
+                </c:pt>
+              </c:strCache>
+            </c:strRef>
+          </c:cat>
+          <c:val>
+            <c:numRef>
+              <c:f>'Chart Data'!$B$2:$B$3</c:f>
+              <c:numCache>
+                <c:formatCode>0.000</c:formatCode>
+                <c:ptCount val="2"/>
+                <c:pt idx="0">
+                  <c:v>0.080189</c:v>
+                </c:pt>
+                <c:pt idx="1">
+                  <c:v>0.079016</c:v>
+                </c:pt>
+              </c:numCache>
+            </c:numRef>
+          </c:val>
+        </c:ser>
+        <c:ser>
+          <c:idx val="1"/>
+          <c:order val="1"/>
+          <c:tx>
+            <c:v>SciPy 1.16.3</c:v>
           </c:tx>
           <c:spPr>
             <a:solidFill xmlns:a="http://schemas.openxmlformats.org/drawingml/2006/main">
@@ -1638,42 +1679,45 @@
           </c:spPr>
           <c:cat>
             <c:strRef>
-              <c:f>'Chart Data'!$A$2:$A$3</c:f>
+              <c:f>'Chart Data'!$C$2:$C$3</c:f>
               <c:strCache>
                 <c:ptCount val="2"/>
                 <c:pt idx="0">
-                  <c:v>C11</c:v>
+                  <c:v>完整进程</c:v>
                 </c:pt>
                 <c:pt idx="1">
-                  <c:v>SciPy 1.16.3</c:v>
+                  <c:v>SciPy预导入</c:v>
                 </c:pt>
               </c:strCache>
             </c:strRef>
           </c:cat>
           <c:val>
             <c:numRef>
-              <c:f>'Chart Data'!$B$2:$B$3</c:f>
+              <c:f>'Chart Data'!$D$2:$D$3</c:f>
               <c:numCache>
-                <c:formatCode>0.000000</c:formatCode>
+                <c:formatCode>0.000</c:formatCode>
                 <c:ptCount val="2"/>
                 <c:pt idx="0">
-                  <c:v>0.080189</c:v>
+                  <c:v>56.401718</c:v>
                 </c:pt>
                 <c:pt idx="1">
-                  <c:v>56.401718</c:v>
+                  <c:v>49.704188</c:v>
                 </c:pt>
               </c:numCache>
             </c:numRef>
           </c:val>
         </c:ser>
         <c:dLbls>
-          <c:numFmt formatCode="0.000000" sourceLinked="0"/>
+          <c:numFmt formatCode="0.000" sourceLinked="0"/>
           <c:txPr>
             <a:bodyPr xmlns:a="http://schemas.openxmlformats.org/drawingml/2006/main" anchorCtr="1"/>
             <a:lstStyle xmlns:a="http://schemas.openxmlformats.org/drawingml/2006/main"/>
             <a:p xmlns:a="http://schemas.openxmlformats.org/drawingml/2006/main">
               <a:pPr>
-                <a:defRPr>
+                <a:defRPr sz="1400">
+                  <a:solidFill>
+                    <a:srgbClr val="FFFFFF"/>
+                  </a:solidFill>
                   <a:latin typeface="Times New Roman"/>
                   <a:ea typeface="楷体_GB2312"/>
                   <a:cs typeface="Times New Roman"/>
@@ -1681,15 +1725,16 @@
               </a:pPr>
             </a:p>
           </c:txPr>
+          <c:dLblPos val="inEnd"/>
           <c:showLegendKey val="0"/>
-          <c:showVal val="0"/>
+          <c:showVal val="1"/>
           <c:showCatName val="0"/>
           <c:showSerName val="0"/>
           <c:showPercent val="0"/>
           <c:showBubbleSize val="0"/>
           <c:showLeaderLines val="0"/>
         </c:dLbls>
-        <c:gapWidth val="85"/>
+        <c:gapWidth val="65"/>
         <c:axId val="48650112"/>
         <c:axId val="48672768"/>
       </c:barChart>
@@ -1785,6 +1830,23 @@
         </a:ln>
       </c:spPr>
     </c:plotArea>
+    <c:legend>
+      <c:legendPos val="b"/>
+      <c:overlay val="0"/>
+      <c:txPr>
+        <a:bodyPr xmlns:a="http://schemas.openxmlformats.org/drawingml/2006/main" anchorCtr="1"/>
+        <a:lstStyle xmlns:a="http://schemas.openxmlformats.org/drawingml/2006/main"/>
+        <a:p xmlns:a="http://schemas.openxmlformats.org/drawingml/2006/main">
+          <a:pPr>
+            <a:defRPr sz="1400">
+              <a:latin typeface="Times New Roman"/>
+              <a:ea typeface="楷体_GB2312"/>
+              <a:cs typeface="Times New Roman"/>
+            </a:defRPr>
+          </a:pPr>
+        </a:p>
+      </c:txPr>
+    </c:legend>
     <c:plotVisOnly val="1"/>
   </c:chart>
   <c:spPr>
@@ -1825,7 +1887,7 @@
           <p:cNvPr id="13" name="workflow-1">
             <a:extLst xmlns:a="http://schemas.openxmlformats.org/drawingml/2006/main">
               <a:ext uri="{FF2B5EF4-FFF2-40B4-BE49-F238E27FC236}">
-                <a16:creationId xmlns:a16="http://schemas.microsoft.com/office/drawing/2014/main" id="{90AC7D24-97A2-4F1B-9A6B-0B3BA57697FB}"/>
+                <a16:creationId xmlns:a16="http://schemas.microsoft.com/office/drawing/2014/main" id="{309A74B1-0312-4394-88BA-B8F7A6DC995C}"/>
               </a:ext>
             </a:extLst>
           </p:cNvPr>
@@ -1909,7 +1971,7 @@
           <p:cNvPr id="2" name="workflow-2">
             <a:extLst xmlns:a="http://schemas.openxmlformats.org/drawingml/2006/main">
               <a:ext uri="{FF2B5EF4-FFF2-40B4-BE49-F238E27FC236}">
-                <a16:creationId xmlns:a16="http://schemas.microsoft.com/office/drawing/2014/main" id="{FC574C30-A7A6-49AD-8E4D-98FA49FD4E8A}"/>
+                <a16:creationId xmlns:a16="http://schemas.microsoft.com/office/drawing/2014/main" id="{33A4ED56-1756-4AA7-AFCC-70094E293677}"/>
               </a:ext>
             </a:extLst>
           </p:cNvPr>
@@ -1993,7 +2055,7 @@
           <p:cNvPr id="3" name="workflow-3">
             <a:extLst xmlns:a="http://schemas.openxmlformats.org/drawingml/2006/main">
               <a:ext uri="{FF2B5EF4-FFF2-40B4-BE49-F238E27FC236}">
-                <a16:creationId xmlns:a16="http://schemas.microsoft.com/office/drawing/2014/main" id="{2915CFCA-E487-4F82-BE97-BAA74A396D8E}"/>
+                <a16:creationId xmlns:a16="http://schemas.microsoft.com/office/drawing/2014/main" id="{0D03111C-B44E-4B95-8972-988A25326C93}"/>
               </a:ext>
             </a:extLst>
           </p:cNvPr>
@@ -2077,7 +2139,7 @@
           <p:cNvPr id="4" name="workflow-4">
             <a:extLst xmlns:a="http://schemas.openxmlformats.org/drawingml/2006/main">
               <a:ext uri="{FF2B5EF4-FFF2-40B4-BE49-F238E27FC236}">
-                <a16:creationId xmlns:a16="http://schemas.microsoft.com/office/drawing/2014/main" id="{87207F62-0CBD-4709-8E4B-88D07622DF7E}"/>
+                <a16:creationId xmlns:a16="http://schemas.microsoft.com/office/drawing/2014/main" id="{B1CC657C-C79E-4B07-A369-787E04BE58EA}"/>
               </a:ext>
             </a:extLst>
           </p:cNvPr>
@@ -2138,7 +2200,7 @@
           <p:cNvPr id="5" name="workflow-5">
             <a:extLst xmlns:a="http://schemas.openxmlformats.org/drawingml/2006/main">
               <a:ext uri="{FF2B5EF4-FFF2-40B4-BE49-F238E27FC236}">
-                <a16:creationId xmlns:a16="http://schemas.microsoft.com/office/drawing/2014/main" id="{7BDCADDB-D66A-478B-B768-F19E71517EEA}"/>
+                <a16:creationId xmlns:a16="http://schemas.microsoft.com/office/drawing/2014/main" id="{553C193B-5EBB-4C28-889A-7A06260B953C}"/>
               </a:ext>
             </a:extLst>
           </p:cNvPr>
@@ -2222,7 +2284,7 @@
           <p:cNvPr id="6" name="workflow-6">
             <a:extLst xmlns:a="http://schemas.openxmlformats.org/drawingml/2006/main">
               <a:ext uri="{FF2B5EF4-FFF2-40B4-BE49-F238E27FC236}">
-                <a16:creationId xmlns:a16="http://schemas.microsoft.com/office/drawing/2014/main" id="{DC602162-DE15-4ED2-85F4-84346A405E8F}"/>
+                <a16:creationId xmlns:a16="http://schemas.microsoft.com/office/drawing/2014/main" id="{CA71A30E-A939-4FEC-A50A-2AB4EBC78ED3}"/>
               </a:ext>
             </a:extLst>
           </p:cNvPr>
@@ -2431,7 +2493,7 @@
           <p:cNvPr id="12" name="">
             <a:extLst xmlns:a="http://schemas.openxmlformats.org/drawingml/2006/main">
               <a:ext uri="{FF2B5EF4-FFF2-40B4-BE49-F238E27FC236}">
-                <a16:creationId xmlns:a16="http://schemas.microsoft.com/office/drawing/2014/main" id="{36D8EF94-8849-4F7D-AAC2-E3D715CF0639}"/>
+                <a16:creationId xmlns:a16="http://schemas.microsoft.com/office/drawing/2014/main" id="{FE6DC56C-6A60-4397-A0EF-A6E4F4834ED4}"/>
               </a:ext>
             </a:extLst>
           </p:cNvPr>
@@ -2486,7 +2548,7 @@
     </p:spTree>
     <p:extLst>
       <p:ext uri="{BB962C8B-B14F-4D97-AF65-F5344CB8AC3E}">
-        <p14:creationId xmlns:p14="http://schemas.microsoft.com/office/powerpoint/2010/main" val="282046115"/>
+        <p14:creationId xmlns:p14="http://schemas.microsoft.com/office/powerpoint/2010/main" val="791180757"/>
       </p:ext>
     </p:extLst>
   </p:cSld>
@@ -2524,7 +2586,7 @@
         </p:xfrm>
         <a:graphic xmlns:a="http://schemas.openxmlformats.org/drawingml/2006/main">
           <a:graphicData uri="http://schemas.openxmlformats.org/drawingml/2006/chart">
-            <c:chart xmlns:r="http://schemas.openxmlformats.org/officeDocument/2006/relationships" xmlns:c="http://schemas.openxmlformats.org/drawingml/2006/chart" r:id="R6b3a5aeac4e84b3d"/>
+            <c:chart xmlns:r="http://schemas.openxmlformats.org/officeDocument/2006/relationships" xmlns:c="http://schemas.openxmlformats.org/drawingml/2006/chart" r:id="R56a2158774714661"/>
           </a:graphicData>
         </a:graphic>
       </p:graphicFrame>
@@ -2533,7 +2595,7 @@
           <p:cNvPr id="2" name="">
             <a:extLst xmlns:a="http://schemas.openxmlformats.org/drawingml/2006/main">
               <a:ext uri="{FF2B5EF4-FFF2-40B4-BE49-F238E27FC236}">
-                <a16:creationId xmlns:a16="http://schemas.microsoft.com/office/drawing/2014/main" id="{7E70E7B1-8680-4E7D-8C12-60A379A64956}"/>
+                <a16:creationId xmlns:a16="http://schemas.microsoft.com/office/drawing/2014/main" id="{AE48F00B-4EE6-4693-B75F-64C9F198E2C1}"/>
               </a:ext>
             </a:extLst>
           </p:cNvPr>
@@ -2590,7 +2652,7 @@
           <p:cNvPr id="3" name="">
             <a:extLst xmlns:a="http://schemas.openxmlformats.org/drawingml/2006/main">
               <a:ext uri="{FF2B5EF4-FFF2-40B4-BE49-F238E27FC236}">
-                <a16:creationId xmlns:a16="http://schemas.microsoft.com/office/drawing/2014/main" id="{E0A24119-B588-4590-B3B5-EA31EF94BA78}"/>
+                <a16:creationId xmlns:a16="http://schemas.microsoft.com/office/drawing/2014/main" id="{4CA85D28-D558-4A5F-880D-36C8C3128F0A}"/>
               </a:ext>
             </a:extLst>
           </p:cNvPr>
@@ -2645,7 +2707,7 @@
     </p:spTree>
     <p:extLst>
       <p:ext uri="{BB962C8B-B14F-4D97-AF65-F5344CB8AC3E}">
-        <p14:creationId xmlns:p14="http://schemas.microsoft.com/office/powerpoint/2010/main" val="265264313"/>
+        <p14:creationId xmlns:p14="http://schemas.microsoft.com/office/powerpoint/2010/main" val="1290590392"/>
       </p:ext>
     </p:extLst>
   </p:cSld>
@@ -2673,17 +2735,17 @@
       </p:grpSpPr>
       <p:graphicFrame>
         <p:nvGraphicFramePr>
-          <p:cNvPr id="7" name="Chart"/>
+          <p:cNvPr id="5" name="Chart"/>
           <p:cNvGraphicFramePr/>
           <p:nvPr/>
         </p:nvGraphicFramePr>
         <p:xfrm>
-          <a:off xmlns:a="http://schemas.openxmlformats.org/drawingml/2006/main" x="133350" y="381000"/>
-          <a:ext xmlns:a="http://schemas.openxmlformats.org/drawingml/2006/main" cx="5219700" cy="2133600"/>
+          <a:off xmlns:a="http://schemas.openxmlformats.org/drawingml/2006/main" x="95250" y="323850"/>
+          <a:ext xmlns:a="http://schemas.openxmlformats.org/drawingml/2006/main" cx="5295900" cy="2190750"/>
         </p:xfrm>
         <a:graphic xmlns:a="http://schemas.openxmlformats.org/drawingml/2006/main">
           <a:graphicData uri="http://schemas.openxmlformats.org/drawingml/2006/chart">
-            <c:chart xmlns:r="http://schemas.openxmlformats.org/officeDocument/2006/relationships" xmlns:c="http://schemas.openxmlformats.org/drawingml/2006/chart" r:id="R58958aaa2d7f46ef"/>
+            <c:chart xmlns:r="http://schemas.openxmlformats.org/officeDocument/2006/relationships" xmlns:c="http://schemas.openxmlformats.org/drawingml/2006/chart" r:id="R6c2ae44f4f7644f8"/>
           </a:graphicData>
         </a:graphic>
       </p:graphicFrame>
@@ -2692,121 +2754,7 @@
           <p:cNvPr id="2" name="">
             <a:extLst xmlns:a="http://schemas.openxmlformats.org/drawingml/2006/main">
               <a:ext uri="{FF2B5EF4-FFF2-40B4-BE49-F238E27FC236}">
-                <a16:creationId xmlns:a16="http://schemas.microsoft.com/office/drawing/2014/main" id="{D96E5DDC-086B-494B-932C-C51408C9F9B5}"/>
-              </a:ext>
-            </a:extLst>
-          </p:cNvPr>
-          <p:cNvSpPr>
-            <a:spLocks xmlns:a="http://schemas.openxmlformats.org/drawingml/2006/main" noGrp="1"/>
-          </p:cNvSpPr>
-          <p:nvPr/>
-        </p:nvSpPr>
-        <p:spPr>
-          <a:xfrm xmlns:a="http://schemas.openxmlformats.org/drawingml/2006/main">
-            <a:off x="3219450" y="762000"/>
-            <a:ext cx="1238250" cy="285750"/>
-          </a:xfrm>
-          <a:prstGeom xmlns:a="http://schemas.openxmlformats.org/drawingml/2006/main" prst="rect">
-            <a:avLst/>
-          </a:prstGeom>
-          <a:noFill xmlns:a="http://schemas.openxmlformats.org/drawingml/2006/main"/>
-          <a:ln xmlns:a="http://schemas.openxmlformats.org/drawingml/2006/main" w="0">
-            <a:noFill/>
-          </a:ln>
-        </p:spPr>
-        <p:txBody>
-          <a:bodyPr xmlns:a="http://schemas.openxmlformats.org/drawingml/2006/main" lIns="0" tIns="0" rIns="0" bIns="0" anchor="ctr">
-            <a:noAutofit/>
-          </a:bodyPr>
-          <a:lstStyle xmlns:a="http://schemas.openxmlformats.org/drawingml/2006/main"/>
-          <a:p xmlns:a="http://schemas.openxmlformats.org/drawingml/2006/main">
-            <a:pPr algn="ctr">
-              <a:defRPr sz="1400">
-                <a:solidFill>
-                  <a:srgbClr val="000000"/>
-                </a:solidFill>
-                <a:latin typeface="Times New Roman"/>
-                <a:ea typeface="楷体_GB2312"/>
-                <a:cs typeface="Times New Roman"/>
-              </a:defRPr>
-            </a:pPr>
-            <a:r>
-              <a:rPr sz="1400">
-                <a:solidFill>
-                  <a:srgbClr val="FFFFFF"/>
-                </a:solidFill>
-                <a:latin typeface="Times New Roman"/>
-                <a:ea typeface="楷体_GB2312"/>
-                <a:cs typeface="Times New Roman"/>
-              </a:rPr>
-              <a:t>56.401718</a:t>
-            </a:r>
-          </a:p>
-        </p:txBody>
-      </p:sp>
-      <p:sp>
-        <p:nvSpPr>
-          <p:cNvPr id="3" name="">
-            <a:extLst xmlns:a="http://schemas.openxmlformats.org/drawingml/2006/main">
-              <a:ext uri="{FF2B5EF4-FFF2-40B4-BE49-F238E27FC236}">
-                <a16:creationId xmlns:a16="http://schemas.microsoft.com/office/drawing/2014/main" id="{7FA01C07-1A88-4AE7-AE5A-7A92FBC443E9}"/>
-              </a:ext>
-            </a:extLst>
-          </p:cNvPr>
-          <p:cNvSpPr>
-            <a:spLocks xmlns:a="http://schemas.openxmlformats.org/drawingml/2006/main" noGrp="1"/>
-          </p:cNvSpPr>
-          <p:nvPr/>
-        </p:nvSpPr>
-        <p:spPr>
-          <a:xfrm xmlns:a="http://schemas.openxmlformats.org/drawingml/2006/main">
-            <a:off x="1190625" y="1628775"/>
-            <a:ext cx="762000" cy="285750"/>
-          </a:xfrm>
-          <a:prstGeom xmlns:a="http://schemas.openxmlformats.org/drawingml/2006/main" prst="rect">
-            <a:avLst/>
-          </a:prstGeom>
-          <a:noFill xmlns:a="http://schemas.openxmlformats.org/drawingml/2006/main"/>
-          <a:ln xmlns:a="http://schemas.openxmlformats.org/drawingml/2006/main" w="0">
-            <a:noFill/>
-          </a:ln>
-        </p:spPr>
-        <p:txBody>
-          <a:bodyPr xmlns:a="http://schemas.openxmlformats.org/drawingml/2006/main" lIns="0" tIns="0" rIns="0" bIns="0" anchor="ctr">
-            <a:noAutofit/>
-          </a:bodyPr>
-          <a:lstStyle xmlns:a="http://schemas.openxmlformats.org/drawingml/2006/main"/>
-          <a:p xmlns:a="http://schemas.openxmlformats.org/drawingml/2006/main">
-            <a:pPr algn="ctr">
-              <a:defRPr sz="1400">
-                <a:solidFill>
-                  <a:srgbClr val="000000"/>
-                </a:solidFill>
-                <a:latin typeface="Times New Roman"/>
-                <a:ea typeface="楷体_GB2312"/>
-                <a:cs typeface="Times New Roman"/>
-              </a:defRPr>
-            </a:pPr>
-            <a:r>
-              <a:rPr sz="1400">
-                <a:solidFill>
-                  <a:srgbClr val="FFFFFF"/>
-                </a:solidFill>
-                <a:latin typeface="Times New Roman"/>
-                <a:ea typeface="楷体_GB2312"/>
-                <a:cs typeface="Times New Roman"/>
-              </a:rPr>
-              <a:t>0.080189</a:t>
-            </a:r>
-          </a:p>
-        </p:txBody>
-      </p:sp>
-      <p:sp>
-        <p:nvSpPr>
-          <p:cNvPr id="4" name="">
-            <a:extLst xmlns:a="http://schemas.openxmlformats.org/drawingml/2006/main">
-              <a:ext uri="{FF2B5EF4-FFF2-40B4-BE49-F238E27FC236}">
-                <a16:creationId xmlns:a16="http://schemas.microsoft.com/office/drawing/2014/main" id="{BB56D2F4-6698-4FE3-AD36-19B68CE2E6E9}"/>
+                <a16:creationId xmlns:a16="http://schemas.microsoft.com/office/drawing/2014/main" id="{9E02FFD7-AFF1-4116-AFAE-E558803BE7C2}"/>
               </a:ext>
             </a:extLst>
           </p:cNvPr>
@@ -2853,17 +2801,17 @@
                 <a:ea typeface="楷体_GB2312"/>
                 <a:cs typeface="楷体_GB2312"/>
               </a:rPr>
-              <a:t>完整进程成本合计 / s（对数刻度）</a:t>
+              <a:t>复算窗口成本合计 / s（对数刻度）</a:t>
             </a:r>
           </a:p>
         </p:txBody>
       </p:sp>
       <p:sp>
         <p:nvSpPr>
-          <p:cNvPr id="5" name="">
+          <p:cNvPr id="3" name="">
             <a:extLst xmlns:a="http://schemas.openxmlformats.org/drawingml/2006/main">
               <a:ext uri="{FF2B5EF4-FFF2-40B4-BE49-F238E27FC236}">
-                <a16:creationId xmlns:a16="http://schemas.microsoft.com/office/drawing/2014/main" id="{5805ABDB-6C46-4FA7-898E-C0DF7D8331B9}"/>
+                <a16:creationId xmlns:a16="http://schemas.microsoft.com/office/drawing/2014/main" id="{097D312E-013E-49EC-BA1E-A8E032113FE6}"/>
               </a:ext>
             </a:extLst>
           </p:cNvPr>
@@ -2910,17 +2858,17 @@
                 <a:ea typeface="楷体_GB2312"/>
                 <a:cs typeface="楷体_GB2312"/>
               </a:rPr>
-              <a:t>每方法24个进程，包含启动、导入和读写</a:t>
+              <a:t>每条件每方法24次；C包含完整启动与读写</a:t>
             </a:r>
           </a:p>
         </p:txBody>
       </p:sp>
       <p:sp>
         <p:nvSpPr>
-          <p:cNvPr id="6" name="">
+          <p:cNvPr id="4" name="">
             <a:extLst xmlns:a="http://schemas.openxmlformats.org/drawingml/2006/main">
               <a:ext uri="{FF2B5EF4-FFF2-40B4-BE49-F238E27FC236}">
-                <a16:creationId xmlns:a16="http://schemas.microsoft.com/office/drawing/2014/main" id="{F6C8E789-DEF3-48CE-81AB-741517F683F7}"/>
+                <a16:creationId xmlns:a16="http://schemas.microsoft.com/office/drawing/2014/main" id="{78975536-EB17-4846-8A33-FFC3371405BA}"/>
               </a:ext>
             </a:extLst>
           </p:cNvPr>
@@ -2967,7 +2915,7 @@
                 <a:ea typeface="楷体_GB2312"/>
                 <a:cs typeface="楷体_GB2312"/>
               </a:rPr>
-              <a:t>范围：固定精确复算任务</a:t>
+              <a:t>预导入准备另计6.560 s；非纯内核比较</a:t>
             </a:r>
           </a:p>
         </p:txBody>
@@ -2975,7 +2923,7 @@
     </p:spTree>
     <p:extLst>
       <p:ext uri="{BB962C8B-B14F-4D97-AF65-F5344CB8AC3E}">
-        <p14:creationId xmlns:p14="http://schemas.microsoft.com/office/powerpoint/2010/main" val="1123129019"/>
+        <p14:creationId xmlns:p14="http://schemas.microsoft.com/office/powerpoint/2010/main" val="442883571"/>
       </p:ext>
     </p:extLst>
   </p:cSld>

</xml_diff>